<commit_message>
Stop tracking IDE settings, drop personal names from README and slides
Co-Authored-By: Claude Opus 5.5 <noreply@anthropic.com>
</commit_message>
<xml_diff>
--- a/Information for Everyone - Project Presentation.pptx
+++ b/Information for Everyone - Project Presentation.pptx
@@ -11593,7 +11593,7 @@
                 <a:cs typeface="Plus Jakarta Sans SemiBold"/>
                 <a:sym typeface="Plus Jakarta Sans SemiBold"/>
               </a:rPr>
-              <a:t>Mehmet Eren Ekşi</a:t>
+              <a:t>CMP2004 Term Project</a:t>
             </a:r>
             <a:endParaRPr/>
           </a:p>
@@ -11699,7 +11699,7 @@
                 <a:cs typeface="Plus Jakarta Sans SemiBold"/>
                 <a:sym typeface="Plus Jakarta Sans SemiBold"/>
               </a:rPr>
-              <a:t>Yiğit Erel</a:t>
+              <a:t>Spring 2026</a:t>
             </a:r>
             <a:endParaRPr/>
           </a:p>

</xml_diff>